<commit_message>
Remove cost breakdown from investment slide — show value-adds only
Labor, supplies, and equipment line items removed. Remaining margin
goes to admin overhead and is not client-facing. Replaced with
client-value rows (all Included): OrangeQC reporting, QA manager,
ownership line, W-2 staff, supply & equipment management.

https://claude.ai/code/session_01HqC6YH1QDUi5RRFTNvERPL
</commit_message>
<xml_diff>
--- a/MDF_Proposal_LogicalSystems_2026-05-28.pptx
+++ b/MDF_Proposal_LogicalSystems_2026-05-28.pptx
@@ -9934,7 +9934,7 @@
         <p:spPr>
           <a:xfrm>
             <a:off x="411480" y="1828800"/>
-            <a:ext cx="4572000" cy="347472"/>
+            <a:ext cx="4572000" cy="384048"/>
           </a:xfrm>
           <a:prstGeom prst="rect">
             <a:avLst/>
@@ -9977,13 +9977,13 @@
             <a:r>
               <a:rPr lang="en-US" sz="1000" dirty="0">
                 <a:solidFill>
-                  <a:srgbClr val="374151"/>
-                </a:solidFill>
-                <a:latin typeface="Calibri" pitchFamily="34" charset="0"/>
-                <a:ea typeface="Calibri" pitchFamily="34" charset="-122"/>
-                <a:cs typeface="Calibri" pitchFamily="34" charset="-120"/>
-              </a:rPr>
-              <a:t>Labor — W-2 Employees</a:t>
+                  <a:srgbClr val="2E7D52"/>
+                </a:solidFill>
+                <a:latin typeface="Calibri" pitchFamily="34" charset="0"/>
+                <a:ea typeface="Calibri" pitchFamily="34" charset="-122"/>
+                <a:cs typeface="Calibri" pitchFamily="34" charset="-120"/>
+              </a:rPr>
+              <a:t>OrangeQC Inspection Reporting</a:t>
             </a:r>
             <a:endParaRPr lang="en-US" sz="1000" dirty="0"/>
           </a:p>
@@ -10014,15 +10014,15 @@
               <a:buNone/>
             </a:pPr>
             <a:r>
-              <a:rPr lang="en-US" sz="1000" b="1" dirty="0">
-                <a:solidFill>
-                  <a:srgbClr val="0D1F3C"/>
-                </a:solidFill>
-                <a:latin typeface="Calibri" pitchFamily="34" charset="0"/>
-                <a:ea typeface="Calibri" pitchFamily="34" charset="-122"/>
-                <a:cs typeface="Calibri" pitchFamily="34" charset="-120"/>
-              </a:rPr>
-              <a:t>$630</a:t>
+              <a:rPr lang="en-US" sz="1000" dirty="0">
+                <a:solidFill>
+                  <a:srgbClr val="2E7D52"/>
+                </a:solidFill>
+                <a:latin typeface="Calibri" pitchFamily="34" charset="0"/>
+                <a:ea typeface="Calibri" pitchFamily="34" charset="-122"/>
+                <a:cs typeface="Calibri" pitchFamily="34" charset="-120"/>
+              </a:rPr>
+              <a:t>Included</a:t>
             </a:r>
             <a:endParaRPr lang="en-US" sz="1000" dirty="0"/>
           </a:p>
@@ -10036,8 +10036,8 @@
         </p:nvSpPr>
         <p:spPr>
           <a:xfrm>
-            <a:off x="411480" y="2176272"/>
-            <a:ext cx="4572000" cy="347472"/>
+            <a:off x="411480" y="2212848"/>
+            <a:ext cx="4572000" cy="384048"/>
           </a:xfrm>
           <a:prstGeom prst="rect">
             <a:avLst/>
@@ -10061,7 +10061,7 @@
         </p:nvSpPr>
         <p:spPr>
           <a:xfrm>
-            <a:off x="548640" y="2249424"/>
+            <a:off x="548640" y="2286000"/>
             <a:ext cx="2926080" cy="219456"/>
           </a:xfrm>
           <a:prstGeom prst="rect">
@@ -10080,13 +10080,13 @@
             <a:r>
               <a:rPr lang="en-US" sz="1000" dirty="0">
                 <a:solidFill>
-                  <a:srgbClr val="374151"/>
-                </a:solidFill>
-                <a:latin typeface="Calibri" pitchFamily="34" charset="0"/>
-                <a:ea typeface="Calibri" pitchFamily="34" charset="-122"/>
-                <a:cs typeface="Calibri" pitchFamily="34" charset="-120"/>
-              </a:rPr>
-              <a:t>Supplies &amp; Consumables (4%)</a:t>
+                  <a:srgbClr val="2E7D52"/>
+                </a:solidFill>
+                <a:latin typeface="Calibri" pitchFamily="34" charset="0"/>
+                <a:ea typeface="Calibri" pitchFamily="34" charset="-122"/>
+                <a:cs typeface="Calibri" pitchFamily="34" charset="-120"/>
+              </a:rPr>
+              <a:t>Dedicated QA Manager</a:t>
             </a:r>
             <a:endParaRPr lang="en-US" sz="1000" dirty="0"/>
           </a:p>
@@ -10100,7 +10100,7 @@
         </p:nvSpPr>
         <p:spPr>
           <a:xfrm>
-            <a:off x="3566160" y="2249424"/>
+            <a:off x="3566160" y="2286000"/>
             <a:ext cx="1234440" cy="219456"/>
           </a:xfrm>
           <a:prstGeom prst="rect">
@@ -10117,15 +10117,15 @@
               <a:buNone/>
             </a:pPr>
             <a:r>
-              <a:rPr lang="en-US" sz="1000" b="1" dirty="0">
-                <a:solidFill>
-                  <a:srgbClr val="0D1F3C"/>
-                </a:solidFill>
-                <a:latin typeface="Calibri" pitchFamily="34" charset="0"/>
-                <a:ea typeface="Calibri" pitchFamily="34" charset="-122"/>
-                <a:cs typeface="Calibri" pitchFamily="34" charset="-120"/>
-              </a:rPr>
-              <a:t>$40</a:t>
+              <a:rPr lang="en-US" sz="1000" dirty="0">
+                <a:solidFill>
+                  <a:srgbClr val="2E7D52"/>
+                </a:solidFill>
+                <a:latin typeface="Calibri" pitchFamily="34" charset="0"/>
+                <a:ea typeface="Calibri" pitchFamily="34" charset="-122"/>
+                <a:cs typeface="Calibri" pitchFamily="34" charset="-120"/>
+              </a:rPr>
+              <a:t>Included</a:t>
             </a:r>
             <a:endParaRPr lang="en-US" sz="1000" dirty="0"/>
           </a:p>
@@ -10139,8 +10139,8 @@
         </p:nvSpPr>
         <p:spPr>
           <a:xfrm>
-            <a:off x="411480" y="2523744"/>
-            <a:ext cx="4572000" cy="347472"/>
+            <a:off x="411480" y="2596896"/>
+            <a:ext cx="4572000" cy="384048"/>
           </a:xfrm>
           <a:prstGeom prst="rect">
             <a:avLst/>
@@ -10164,7 +10164,7 @@
         </p:nvSpPr>
         <p:spPr>
           <a:xfrm>
-            <a:off x="548640" y="2596896"/>
+            <a:off x="548640" y="2670048"/>
             <a:ext cx="2926080" cy="219456"/>
           </a:xfrm>
           <a:prstGeom prst="rect">
@@ -10183,13 +10183,13 @@
             <a:r>
               <a:rPr lang="en-US" sz="1000" dirty="0">
                 <a:solidFill>
-                  <a:srgbClr val="374151"/>
-                </a:solidFill>
-                <a:latin typeface="Calibri" pitchFamily="34" charset="0"/>
-                <a:ea typeface="Calibri" pitchFamily="34" charset="-122"/>
-                <a:cs typeface="Calibri" pitchFamily="34" charset="-120"/>
-              </a:rPr>
-              <a:t>Equipment &amp; Maintenance (3%)</a:t>
+                  <a:srgbClr val="2E7D52"/>
+                </a:solidFill>
+                <a:latin typeface="Calibri" pitchFamily="34" charset="0"/>
+                <a:ea typeface="Calibri" pitchFamily="34" charset="-122"/>
+                <a:cs typeface="Calibri" pitchFamily="34" charset="-120"/>
+              </a:rPr>
+              <a:t>Ownership Direct Line</a:t>
             </a:r>
             <a:endParaRPr lang="en-US" sz="1000" dirty="0"/>
           </a:p>
@@ -10203,7 +10203,7 @@
         </p:nvSpPr>
         <p:spPr>
           <a:xfrm>
-            <a:off x="3566160" y="2596896"/>
+            <a:off x="3566160" y="2670048"/>
             <a:ext cx="1234440" cy="219456"/>
           </a:xfrm>
           <a:prstGeom prst="rect">
@@ -10220,15 +10220,15 @@
               <a:buNone/>
             </a:pPr>
             <a:r>
-              <a:rPr lang="en-US" sz="1000" b="1" dirty="0">
-                <a:solidFill>
-                  <a:srgbClr val="0D1F3C"/>
-                </a:solidFill>
-                <a:latin typeface="Calibri" pitchFamily="34" charset="0"/>
-                <a:ea typeface="Calibri" pitchFamily="34" charset="-122"/>
-                <a:cs typeface="Calibri" pitchFamily="34" charset="-120"/>
-              </a:rPr>
-              <a:t>$30</a:t>
+              <a:rPr lang="en-US" sz="1000" dirty="0">
+                <a:solidFill>
+                  <a:srgbClr val="2E7D52"/>
+                </a:solidFill>
+                <a:latin typeface="Calibri" pitchFamily="34" charset="0"/>
+                <a:ea typeface="Calibri" pitchFamily="34" charset="-122"/>
+                <a:cs typeface="Calibri" pitchFamily="34" charset="-120"/>
+              </a:rPr>
+              <a:t>Included</a:t>
             </a:r>
             <a:endParaRPr lang="en-US" sz="1000" dirty="0"/>
           </a:p>
@@ -10242,8 +10242,8 @@
         </p:nvSpPr>
         <p:spPr>
           <a:xfrm>
-            <a:off x="411480" y="2871216"/>
-            <a:ext cx="4572000" cy="347472"/>
+            <a:off x="411480" y="2980944"/>
+            <a:ext cx="4572000" cy="384048"/>
           </a:xfrm>
           <a:prstGeom prst="rect">
             <a:avLst/>
@@ -10267,7 +10267,7 @@
         </p:nvSpPr>
         <p:spPr>
           <a:xfrm>
-            <a:off x="548640" y="2944368"/>
+            <a:off x="548640" y="3054096"/>
             <a:ext cx="2926080" cy="219456"/>
           </a:xfrm>
           <a:prstGeom prst="rect">
@@ -10292,7 +10292,7 @@
                 <a:ea typeface="Calibri" pitchFamily="34" charset="-122"/>
                 <a:cs typeface="Calibri" pitchFamily="34" charset="-120"/>
               </a:rPr>
-              <a:t>OrangeQC Reporting</a:t>
+              <a:t>W-2 Employed Staff</a:t>
             </a:r>
             <a:endParaRPr lang="en-US" sz="1000" dirty="0"/>
           </a:p>
@@ -10306,7 +10306,7 @@
         </p:nvSpPr>
         <p:spPr>
           <a:xfrm>
-            <a:off x="3566160" y="2944368"/>
+            <a:off x="3566160" y="3054096"/>
             <a:ext cx="1234440" cy="219456"/>
           </a:xfrm>
           <a:prstGeom prst="rect">
@@ -10345,8 +10345,8 @@
         </p:nvSpPr>
         <p:spPr>
           <a:xfrm>
-            <a:off x="411480" y="3218688"/>
-            <a:ext cx="4572000" cy="347472"/>
+            <a:off x="411480" y="3364992"/>
+            <a:ext cx="4572000" cy="384048"/>
           </a:xfrm>
           <a:prstGeom prst="rect">
             <a:avLst/>
@@ -10370,7 +10370,7 @@
         </p:nvSpPr>
         <p:spPr>
           <a:xfrm>
-            <a:off x="548640" y="3291840"/>
+            <a:off x="548640" y="3438144"/>
             <a:ext cx="2926080" cy="219456"/>
           </a:xfrm>
           <a:prstGeom prst="rect">
@@ -10395,7 +10395,7 @@
                 <a:ea typeface="Calibri" pitchFamily="34" charset="-122"/>
                 <a:cs typeface="Calibri" pitchFamily="34" charset="-120"/>
               </a:rPr>
-              <a:t>Dedicated QA Manager</a:t>
+              <a:t>Supply &amp; Equipment Management</a:t>
             </a:r>
             <a:endParaRPr lang="en-US" sz="1000" dirty="0"/>
           </a:p>
@@ -10409,7 +10409,7 @@
         </p:nvSpPr>
         <p:spPr>
           <a:xfrm>
-            <a:off x="3566160" y="3291840"/>
+            <a:off x="3566160" y="3438144"/>
             <a:ext cx="1234440" cy="219456"/>
           </a:xfrm>
           <a:prstGeom prst="rect">
@@ -10448,110 +10448,7 @@
         </p:nvSpPr>
         <p:spPr>
           <a:xfrm>
-            <a:off x="411480" y="3566160"/>
-            <a:ext cx="4572000" cy="347472"/>
-          </a:xfrm>
-          <a:prstGeom prst="rect">
-            <a:avLst/>
-          </a:prstGeom>
-          <a:solidFill>
-            <a:srgbClr val="F9FAFB"/>
-          </a:solidFill>
-          <a:ln w="12700">
-            <a:solidFill>
-              <a:srgbClr val="F3F4F6"/>
-            </a:solidFill>
-            <a:prstDash val="solid"/>
-          </a:ln>
-        </p:spPr>
-      </p:sp>
-      <p:sp>
-        <p:nvSpPr>
-          <p:cNvPr id="25" name="Text 23"/>
-          <p:cNvSpPr/>
-          <p:nvPr/>
-        </p:nvSpPr>
-        <p:spPr>
-          <a:xfrm>
-            <a:off x="548640" y="3639312"/>
-            <a:ext cx="2926080" cy="219456"/>
-          </a:xfrm>
-          <a:prstGeom prst="rect">
-            <a:avLst/>
-          </a:prstGeom>
-          <a:noFill/>
-          <a:ln/>
-        </p:spPr>
-        <p:txBody>
-          <a:bodyPr wrap="square" lIns="0" tIns="0" rIns="0" bIns="0" rtlCol="0" anchor="ctr"/>
-          <a:lstStyle/>
-          <a:p>
-            <a:pPr indent="0" marL="0">
-              <a:buNone/>
-            </a:pPr>
-            <a:r>
-              <a:rPr lang="en-US" sz="1000" dirty="0">
-                <a:solidFill>
-                  <a:srgbClr val="2E7D52"/>
-                </a:solidFill>
-                <a:latin typeface="Calibri" pitchFamily="34" charset="0"/>
-                <a:ea typeface="Calibri" pitchFamily="34" charset="-122"/>
-                <a:cs typeface="Calibri" pitchFamily="34" charset="-120"/>
-              </a:rPr>
-              <a:t>Ownership Direct Line</a:t>
-            </a:r>
-            <a:endParaRPr lang="en-US" sz="1000" dirty="0"/>
-          </a:p>
-        </p:txBody>
-      </p:sp>
-      <p:sp>
-        <p:nvSpPr>
-          <p:cNvPr id="26" name="Text 24"/>
-          <p:cNvSpPr/>
-          <p:nvPr/>
-        </p:nvSpPr>
-        <p:spPr>
-          <a:xfrm>
-            <a:off x="3566160" y="3639312"/>
-            <a:ext cx="1234440" cy="219456"/>
-          </a:xfrm>
-          <a:prstGeom prst="rect">
-            <a:avLst/>
-          </a:prstGeom>
-          <a:noFill/>
-          <a:ln/>
-        </p:spPr>
-        <p:txBody>
-          <a:bodyPr wrap="square" lIns="0" tIns="0" rIns="0" bIns="0" rtlCol="0" anchor="ctr"/>
-          <a:lstStyle/>
-          <a:p>
-            <a:pPr algn="r" indent="0" marL="0">
-              <a:buNone/>
-            </a:pPr>
-            <a:r>
-              <a:rPr lang="en-US" sz="1000" dirty="0">
-                <a:solidFill>
-                  <a:srgbClr val="2E7D52"/>
-                </a:solidFill>
-                <a:latin typeface="Calibri" pitchFamily="34" charset="0"/>
-                <a:ea typeface="Calibri" pitchFamily="34" charset="-122"/>
-                <a:cs typeface="Calibri" pitchFamily="34" charset="-120"/>
-              </a:rPr>
-              <a:t>Included</a:t>
-            </a:r>
-            <a:endParaRPr lang="en-US" sz="1000" dirty="0"/>
-          </a:p>
-        </p:txBody>
-      </p:sp>
-      <p:sp>
-        <p:nvSpPr>
-          <p:cNvPr id="27" name="Shape 25"/>
-          <p:cNvSpPr/>
-          <p:nvPr/>
-        </p:nvSpPr>
-        <p:spPr>
-          <a:xfrm>
-            <a:off x="411480" y="3968496"/>
+            <a:off x="411480" y="3803904"/>
             <a:ext cx="4572000" cy="420624"/>
           </a:xfrm>
           <a:prstGeom prst="rect">
@@ -10570,13 +10467,13 @@
       </p:sp>
       <p:sp>
         <p:nvSpPr>
-          <p:cNvPr id="28" name="Text 26"/>
-          <p:cNvSpPr/>
-          <p:nvPr/>
-        </p:nvSpPr>
-        <p:spPr>
-          <a:xfrm>
-            <a:off x="566928" y="4078224"/>
+          <p:cNvPr id="25" name="Text 23"/>
+          <p:cNvSpPr/>
+          <p:nvPr/>
+        </p:nvSpPr>
+        <p:spPr>
+          <a:xfrm>
+            <a:off x="566928" y="3913632"/>
             <a:ext cx="2560320" cy="237744"/>
           </a:xfrm>
           <a:prstGeom prst="rect">
@@ -10609,13 +10506,13 @@
       </p:sp>
       <p:sp>
         <p:nvSpPr>
-          <p:cNvPr id="29" name="Text 27"/>
-          <p:cNvSpPr/>
-          <p:nvPr/>
-        </p:nvSpPr>
-        <p:spPr>
-          <a:xfrm>
-            <a:off x="3291840" y="4059936"/>
+          <p:cNvPr id="26" name="Text 24"/>
+          <p:cNvSpPr/>
+          <p:nvPr/>
+        </p:nvSpPr>
+        <p:spPr>
+          <a:xfrm>
+            <a:off x="3291840" y="3895344"/>
             <a:ext cx="1508760" cy="274320"/>
           </a:xfrm>
           <a:prstGeom prst="rect">
@@ -10648,7 +10545,7 @@
       </p:sp>
       <p:sp>
         <p:nvSpPr>
-          <p:cNvPr id="30" name="Shape 28"/>
+          <p:cNvPr id="27" name="Shape 25"/>
           <p:cNvSpPr/>
           <p:nvPr/>
         </p:nvSpPr>
@@ -10673,7 +10570,7 @@
       </p:sp>
       <p:sp>
         <p:nvSpPr>
-          <p:cNvPr id="31" name="Text 29"/>
+          <p:cNvPr id="28" name="Text 26"/>
           <p:cNvSpPr/>
           <p:nvPr/>
         </p:nvSpPr>
@@ -10712,7 +10609,7 @@
       </p:sp>
       <p:sp>
         <p:nvSpPr>
-          <p:cNvPr id="32" name="Text 30"/>
+          <p:cNvPr id="29" name="Text 27"/>
           <p:cNvSpPr/>
           <p:nvPr/>
         </p:nvSpPr>
@@ -10774,7 +10671,7 @@
       </p:sp>
       <p:sp>
         <p:nvSpPr>
-          <p:cNvPr id="33" name="Text 31"/>
+          <p:cNvPr id="30" name="Text 28"/>
           <p:cNvSpPr/>
           <p:nvPr/>
         </p:nvSpPr>
@@ -10813,7 +10710,7 @@
       </p:sp>
       <p:sp>
         <p:nvSpPr>
-          <p:cNvPr id="34" name="Shape 32"/>
+          <p:cNvPr id="31" name="Shape 29"/>
           <p:cNvSpPr/>
           <p:nvPr/>
         </p:nvSpPr>
@@ -10838,7 +10735,7 @@
       </p:sp>
       <p:sp>
         <p:nvSpPr>
-          <p:cNvPr id="35" name="Text 33"/>
+          <p:cNvPr id="32" name="Text 30"/>
           <p:cNvSpPr/>
           <p:nvPr/>
         </p:nvSpPr>
@@ -10880,7 +10777,7 @@
       </p:sp>
       <p:sp>
         <p:nvSpPr>
-          <p:cNvPr id="36" name="Text 34"/>
+          <p:cNvPr id="33" name="Text 31"/>
           <p:cNvSpPr/>
           <p:nvPr/>
         </p:nvSpPr>
@@ -10919,7 +10816,7 @@
       </p:sp>
       <p:sp>
         <p:nvSpPr>
-          <p:cNvPr id="37" name="Shape 35"/>
+          <p:cNvPr id="34" name="Shape 32"/>
           <p:cNvSpPr/>
           <p:nvPr/>
         </p:nvSpPr>
@@ -10944,7 +10841,7 @@
       </p:sp>
       <p:sp>
         <p:nvSpPr>
-          <p:cNvPr id="38" name="Text 36"/>
+          <p:cNvPr id="35" name="Text 33"/>
           <p:cNvSpPr/>
           <p:nvPr/>
         </p:nvSpPr>
@@ -10986,7 +10883,7 @@
       </p:sp>
       <p:sp>
         <p:nvSpPr>
-          <p:cNvPr id="39" name="Text 37"/>
+          <p:cNvPr id="36" name="Text 34"/>
           <p:cNvSpPr/>
           <p:nvPr/>
         </p:nvSpPr>
@@ -11025,7 +10922,7 @@
       </p:sp>
       <p:sp>
         <p:nvSpPr>
-          <p:cNvPr id="40" name="Shape 38"/>
+          <p:cNvPr id="37" name="Shape 35"/>
           <p:cNvSpPr/>
           <p:nvPr/>
         </p:nvSpPr>
@@ -11050,7 +10947,7 @@
       </p:sp>
       <p:sp>
         <p:nvSpPr>
-          <p:cNvPr id="41" name="Text 39"/>
+          <p:cNvPr id="38" name="Text 36"/>
           <p:cNvSpPr/>
           <p:nvPr/>
         </p:nvSpPr>
@@ -11092,7 +10989,7 @@
       </p:sp>
       <p:sp>
         <p:nvSpPr>
-          <p:cNvPr id="42" name="Text 40"/>
+          <p:cNvPr id="39" name="Text 37"/>
           <p:cNvSpPr/>
           <p:nvPr/>
         </p:nvSpPr>
@@ -11131,7 +11028,7 @@
       </p:sp>
       <p:sp>
         <p:nvSpPr>
-          <p:cNvPr id="43" name="Shape 41"/>
+          <p:cNvPr id="40" name="Shape 38"/>
           <p:cNvSpPr/>
           <p:nvPr/>
         </p:nvSpPr>
@@ -11156,7 +11053,7 @@
       </p:sp>
       <p:sp>
         <p:nvSpPr>
-          <p:cNvPr id="44" name="Text 42"/>
+          <p:cNvPr id="41" name="Text 39"/>
           <p:cNvSpPr/>
           <p:nvPr/>
         </p:nvSpPr>
@@ -11198,7 +11095,7 @@
       </p:sp>
       <p:sp>
         <p:nvSpPr>
-          <p:cNvPr id="45" name="Text 43"/>
+          <p:cNvPr id="42" name="Text 40"/>
           <p:cNvSpPr/>
           <p:nvPr/>
         </p:nvSpPr>
@@ -11237,7 +11134,7 @@
       </p:sp>
       <p:sp>
         <p:nvSpPr>
-          <p:cNvPr id="46" name="Shape 44"/>
+          <p:cNvPr id="43" name="Shape 41"/>
           <p:cNvSpPr/>
           <p:nvPr/>
         </p:nvSpPr>
@@ -11262,7 +11159,7 @@
       </p:sp>
       <p:sp>
         <p:nvSpPr>
-          <p:cNvPr id="47" name="Text 45"/>
+          <p:cNvPr id="44" name="Text 42"/>
           <p:cNvSpPr/>
           <p:nvPr/>
         </p:nvSpPr>
@@ -11304,7 +11201,7 @@
       </p:sp>
       <p:sp>
         <p:nvSpPr>
-          <p:cNvPr id="48" name="Shape 46"/>
+          <p:cNvPr id="45" name="Shape 43"/>
           <p:cNvSpPr/>
           <p:nvPr/>
         </p:nvSpPr>
@@ -11329,7 +11226,7 @@
       </p:sp>
       <p:sp>
         <p:nvSpPr>
-          <p:cNvPr id="49" name="Text 47"/>
+          <p:cNvPr id="46" name="Text 44"/>
           <p:cNvSpPr/>
           <p:nvPr/>
         </p:nvSpPr>
@@ -11368,7 +11265,7 @@
       </p:sp>
       <p:sp>
         <p:nvSpPr>
-          <p:cNvPr id="50" name="Text 48"/>
+          <p:cNvPr id="47" name="Text 45"/>
           <p:cNvSpPr/>
           <p:nvPr/>
         </p:nvSpPr>
@@ -11407,7 +11304,7 @@
       </p:sp>
       <p:pic>
         <p:nvPicPr>
-          <p:cNvPr id="51" name="Image 0" descr="./mdf_logo_white.png">    </p:cNvPr>
+          <p:cNvPr id="48" name="Image 0" descr="./mdf_logo_white.png">    </p:cNvPr>
           <p:cNvPicPr>
             <a:picLocks noChangeAspect="1"/>
           </p:cNvPicPr>

</xml_diff>